<commit_message>
docs(docker): record verified deployment and update slide ten and model card
</commit_message>
<xml_diff>
--- a/presentation/tynys_complete_13slides_kz.pptx
+++ b/presentation/tynys_complete_13slides_kz.pptx
@@ -2,25 +2,25 @@
 <file path=ppt/presentation.xml><?xml version="1.0" encoding="utf-8"?>
 <p:presentation xmlns:p="http://schemas.openxmlformats.org/presentationml/2006/main">
   <p:sldMasterIdLst>
-    <p:sldMasterId xmlns:r="http://schemas.openxmlformats.org/officeDocument/2006/relationships" id="2147483648" r:id="R453ca27886dc4e43"/>
+    <p:sldMasterId xmlns:r="http://schemas.openxmlformats.org/officeDocument/2006/relationships" id="2147483648" r:id="R7133b67604874e45"/>
   </p:sldMasterIdLst>
   <p:notesMasterIdLst>
-    <p:notesMasterId xmlns:r="http://schemas.openxmlformats.org/officeDocument/2006/relationships" r:id="R3a1682a86bbf4776"/>
+    <p:notesMasterId xmlns:r="http://schemas.openxmlformats.org/officeDocument/2006/relationships" r:id="Rc726b13185bb4af5"/>
   </p:notesMasterIdLst>
   <p:sldIdLst>
-    <p:sldId xmlns:r="http://schemas.openxmlformats.org/officeDocument/2006/relationships" id="256" r:id="R9fe647e9cfb14965"/>
-    <p:sldId xmlns:r="http://schemas.openxmlformats.org/officeDocument/2006/relationships" id="257" r:id="R450cf0a65bfd4b0a"/>
-    <p:sldId xmlns:r="http://schemas.openxmlformats.org/officeDocument/2006/relationships" id="258" r:id="R2ea737c52e5b47c6"/>
-    <p:sldId xmlns:r="http://schemas.openxmlformats.org/officeDocument/2006/relationships" id="259" r:id="Re44983c8273649b8"/>
-    <p:sldId xmlns:r="http://schemas.openxmlformats.org/officeDocument/2006/relationships" id="260" r:id="R77a5cf4ce1c04607"/>
-    <p:sldId xmlns:r="http://schemas.openxmlformats.org/officeDocument/2006/relationships" id="261" r:id="Ra2181ae792404833"/>
-    <p:sldId xmlns:r="http://schemas.openxmlformats.org/officeDocument/2006/relationships" id="262" r:id="R544916e6d50f4ac4"/>
-    <p:sldId xmlns:r="http://schemas.openxmlformats.org/officeDocument/2006/relationships" id="263" r:id="R84461fcd4fc84593"/>
-    <p:sldId xmlns:r="http://schemas.openxmlformats.org/officeDocument/2006/relationships" id="264" r:id="R56fdf499a45a43fd"/>
-    <p:sldId xmlns:r="http://schemas.openxmlformats.org/officeDocument/2006/relationships" id="265" r:id="R4b833e65d72c4c21"/>
-    <p:sldId xmlns:r="http://schemas.openxmlformats.org/officeDocument/2006/relationships" id="266" r:id="R2834ae26e5c04376"/>
-    <p:sldId xmlns:r="http://schemas.openxmlformats.org/officeDocument/2006/relationships" id="267" r:id="R3cd0f97bc93e4c12"/>
-    <p:sldId xmlns:r="http://schemas.openxmlformats.org/officeDocument/2006/relationships" id="268" r:id="R3e8259c61b6c4e32"/>
+    <p:sldId xmlns:r="http://schemas.openxmlformats.org/officeDocument/2006/relationships" id="256" r:id="R8ce250daa19b4396"/>
+    <p:sldId xmlns:r="http://schemas.openxmlformats.org/officeDocument/2006/relationships" id="257" r:id="R42dbae8a950347ee"/>
+    <p:sldId xmlns:r="http://schemas.openxmlformats.org/officeDocument/2006/relationships" id="258" r:id="R10bb771b51714ab4"/>
+    <p:sldId xmlns:r="http://schemas.openxmlformats.org/officeDocument/2006/relationships" id="259" r:id="Ra8c32243a0404733"/>
+    <p:sldId xmlns:r="http://schemas.openxmlformats.org/officeDocument/2006/relationships" id="260" r:id="R1a6c93958c334fcf"/>
+    <p:sldId xmlns:r="http://schemas.openxmlformats.org/officeDocument/2006/relationships" id="261" r:id="Rcc8afae33ab04c85"/>
+    <p:sldId xmlns:r="http://schemas.openxmlformats.org/officeDocument/2006/relationships" id="262" r:id="R00d2ea93340644b2"/>
+    <p:sldId xmlns:r="http://schemas.openxmlformats.org/officeDocument/2006/relationships" id="263" r:id="R51e75400c4484ae7"/>
+    <p:sldId xmlns:r="http://schemas.openxmlformats.org/officeDocument/2006/relationships" id="264" r:id="R7b6439df16a244e5"/>
+    <p:sldId xmlns:r="http://schemas.openxmlformats.org/officeDocument/2006/relationships" id="265" r:id="R7c23923ccf8e414d"/>
+    <p:sldId xmlns:r="http://schemas.openxmlformats.org/officeDocument/2006/relationships" id="266" r:id="R434027b0e27b48a1"/>
+    <p:sldId xmlns:r="http://schemas.openxmlformats.org/officeDocument/2006/relationships" id="267" r:id="R854e2d146a3c4ea3"/>
+    <p:sldId xmlns:r="http://schemas.openxmlformats.org/officeDocument/2006/relationships" id="268" r:id="Rc463d8a141e34166"/>
   </p:sldIdLst>
   <p:sldSz cx="12192000" cy="6858000"/>
   <p:notesSz cx="6858000" cy="9144000"/>
@@ -534,7 +534,17 @@
           <a:lstStyle xmlns:a="http://schemas.openxmlformats.org/drawingml/2006/main"/>
           <a:p xmlns:a="http://schemas.openxmlformats.org/drawingml/2006/main">
             <a:r>
-              <a:t>Ensemble, калибрлеу, OOD және DICOM дайын. 56 жергілікті тест өтті. Үш белгіге жеке эксперимент жүргізілді, бірақ сайтқа қосылған жоқ. Docker daemon өшірулі болғандықтан контейнер тексерілмеді. Келесі жұмыс — деректерді кеңейтіп, белгілерді мамандармен тексеру.</a:t>
+              <a:t>Ensemble, калибрлеу, OOD және DICOM дайын. 56 жергілікті тест өтті. Үш белгіге жеке эксперимент жүргізілді, сайтқа қосылмады. Docker build/run тексерілді: Server 29.8.1, image tynys, көлемі 3.28GB. 7860-та жергілікті сервер болғандықтан контейнерді 7861 портында сынадым. PNG және CR DICOM 200, CT DICOM және мәтінді JPG 400. PDF екі бет болып шықты. Ready, OOD, McNemar дайын, T=0,97995943. Traceback жоқ, контейнер тоқтатылып автоматты жойылды. Hugging Face Space-қа жариялау орындалған жоқ.</a:t>
+            </a:r>
+          </a:p>
+          <a:p xmlns:a="http://schemas.openxmlformats.org/drawingml/2006/main">
+            <a:r>
+              <a:t/>
+            </a:r>
+          </a:p>
+          <a:p xmlns:a="http://schemas.openxmlformats.org/drawingml/2006/main">
+            <a:r>
+              <a:t>Дереккөз: training/docker_evidence/verification.json; live_result.json; container_logs.txt.</a:t>
             </a:r>
           </a:p>
         </p:txBody>
@@ -3227,12 +3237,12 @@
   </p:cSld>
   <p:clrMap bg1="lt1" tx1="dk1" bg2="lt2" tx2="dk2" accent1="accent1" accent2="accent2" accent3="accent3" accent4="accent4" accent5="accent5" accent6="accent6" hlink="hlink" folHlink="folHlink"/>
   <p:sldLayoutIdLst>
-    <p:sldLayoutId xmlns:r="http://schemas.openxmlformats.org/officeDocument/2006/relationships" id="2147483649" r:id="Re4da53510e9142c2"/>
-    <p:sldLayoutId xmlns:r="http://schemas.openxmlformats.org/officeDocument/2006/relationships" id="2147483650" r:id="R2730f1f500a84cb8"/>
-    <p:sldLayoutId xmlns:r="http://schemas.openxmlformats.org/officeDocument/2006/relationships" id="2147483651" r:id="R235df686a9ed42eb"/>
-    <p:sldLayoutId xmlns:r="http://schemas.openxmlformats.org/officeDocument/2006/relationships" id="2147483652" r:id="R3425e67f587d48ef"/>
-    <p:sldLayoutId xmlns:r="http://schemas.openxmlformats.org/officeDocument/2006/relationships" id="2147483653" r:id="Ra122d5383e2a4980"/>
-    <p:sldLayoutId xmlns:r="http://schemas.openxmlformats.org/officeDocument/2006/relationships" id="2147483654" r:id="R25061735d34d4ffc"/>
+    <p:sldLayoutId xmlns:r="http://schemas.openxmlformats.org/officeDocument/2006/relationships" id="2147483649" r:id="R2be6fa4635e540e0"/>
+    <p:sldLayoutId xmlns:r="http://schemas.openxmlformats.org/officeDocument/2006/relationships" id="2147483650" r:id="R02908bd480144b28"/>
+    <p:sldLayoutId xmlns:r="http://schemas.openxmlformats.org/officeDocument/2006/relationships" id="2147483651" r:id="Rdd2d9481874c48dd"/>
+    <p:sldLayoutId xmlns:r="http://schemas.openxmlformats.org/officeDocument/2006/relationships" id="2147483652" r:id="R77d303c3b42543d9"/>
+    <p:sldLayoutId xmlns:r="http://schemas.openxmlformats.org/officeDocument/2006/relationships" id="2147483653" r:id="Rdcfd2d9f333d49a6"/>
+    <p:sldLayoutId xmlns:r="http://schemas.openxmlformats.org/officeDocument/2006/relationships" id="2147483654" r:id="R44126239cce04f8f"/>
   </p:sldLayoutIdLst>
   <p:txStyles>
     <p:titleStyle>
@@ -3852,7 +3862,7 @@
           <p:cNvPr id="2" name="">
             <a:extLst xmlns:a="http://schemas.openxmlformats.org/drawingml/2006/main">
               <a:ext uri="{FF2B5EF4-FFF2-40B4-BE49-F238E27FC236}">
-                <a16:creationId xmlns:a16="http://schemas.microsoft.com/office/drawing/2014/main" id="{7909810E-A05B-43F5-AFE8-5115A34FB202}"/>
+                <a16:creationId xmlns:a16="http://schemas.microsoft.com/office/drawing/2014/main" id="{F0087381-6866-4165-87E8-448B1F5DB1AD}"/>
               </a:ext>
             </a:extLst>
           </p:cNvPr>
@@ -3862,7 +3872,7 @@
           <p:nvPr/>
         </p:nvPicPr>
         <p:blipFill>
-          <a:blip xmlns:r="http://schemas.openxmlformats.org/officeDocument/2006/relationships" xmlns:a="http://schemas.openxmlformats.org/drawingml/2006/main" r:embed="Rfc102c6c90f443a4"/>
+          <a:blip xmlns:r="http://schemas.openxmlformats.org/officeDocument/2006/relationships" xmlns:a="http://schemas.openxmlformats.org/drawingml/2006/main" r:embed="R4391085b0def4d7d"/>
           <a:stretch xmlns:a="http://schemas.openxmlformats.org/drawingml/2006/main"/>
         </p:blipFill>
         <p:spPr>
@@ -4529,6 +4539,30 @@
               <a:t>56 тест және CI</a:t>
             </a:r>
           </a:p>
+          <a:p xmlns:a="http://schemas.openxmlformats.org/drawingml/2006/main">
+            <a:pPr>
+              <a:buNone/>
+              <a:defRPr sz="2250" b="0">
+                <a:solidFill>
+                  <a:srgbClr val="FFFFFF"/>
+                </a:solidFill>
+                <a:latin typeface="Arial"/>
+                <a:ea typeface="Arial"/>
+                <a:cs typeface="Arial"/>
+              </a:defRPr>
+            </a:pPr>
+            <a:r>
+              <a:rPr sz="2250" b="0">
+                <a:solidFill>
+                  <a:srgbClr val="FFFFFF"/>
+                </a:solidFill>
+                <a:latin typeface="Arial"/>
+                <a:ea typeface="Arial"/>
+                <a:cs typeface="Arial"/>
+              </a:rPr>
+              <a:t>Docker build/run тексерілді</a:t>
+            </a:r>
+          </a:p>
         </p:txBody>
       </p:sp>
       <p:sp>
@@ -5051,7 +5085,7 @@
           <p:cNvPr id="3" name="">
             <a:extLst xmlns:a="http://schemas.openxmlformats.org/drawingml/2006/main">
               <a:ext uri="{FF2B5EF4-FFF2-40B4-BE49-F238E27FC236}">
-                <a16:creationId xmlns:a16="http://schemas.microsoft.com/office/drawing/2014/main" id="{A99020A7-6A64-48D2-A4DD-0AE0D0A6C2FD}"/>
+                <a16:creationId xmlns:a16="http://schemas.microsoft.com/office/drawing/2014/main" id="{7100581A-A842-4B21-A8C0-0FD0B9782DAF}"/>
               </a:ext>
             </a:extLst>
           </p:cNvPr>
@@ -7120,6 +7154,7 @@
           </a:lstStyle>
           <a:p xmlns:a="http://schemas.openxmlformats.org/drawingml/2006/main">
             <a:pPr>
+              <a:buNone/>
               <a:defRPr sz="3075" b="1">
                 <a:solidFill>
                   <a:srgbClr val="193E3A"/>
@@ -7148,7 +7183,7 @@
           <p:cNvPr id="2" name="">
             <a:extLst xmlns:a="http://schemas.openxmlformats.org/drawingml/2006/main">
               <a:ext uri="{FF2B5EF4-FFF2-40B4-BE49-F238E27FC236}">
-                <a16:creationId xmlns:a16="http://schemas.microsoft.com/office/drawing/2014/main" id="{EDA01C8E-AE98-4487-AB90-B62CC220A4D9}"/>
+                <a16:creationId xmlns:a16="http://schemas.microsoft.com/office/drawing/2014/main" id="{FA455FDA-BA04-44E3-939B-574507BEAEAE}"/>
               </a:ext>
             </a:extLst>
           </p:cNvPr>
@@ -7802,6 +7837,7 @@
           </a:lstStyle>
           <a:p xmlns:a="http://schemas.openxmlformats.org/drawingml/2006/main">
             <a:pPr>
+              <a:buNone/>
               <a:defRPr sz="2250" b="1">
                 <a:solidFill>
                   <a:srgbClr val="087F77"/>
@@ -7868,6 +7904,7 @@
           </a:lstStyle>
           <a:p xmlns:a="http://schemas.openxmlformats.org/drawingml/2006/main">
             <a:pPr>
+              <a:buNone/>
               <a:defRPr sz="2025" b="0">
                 <a:solidFill>
                   <a:srgbClr val="193E3A"/>
@@ -7891,6 +7928,7 @@
           </a:p>
           <a:p xmlns:a="http://schemas.openxmlformats.org/drawingml/2006/main">
             <a:pPr>
+              <a:buNone/>
               <a:defRPr sz="2025" b="0">
                 <a:solidFill>
                   <a:srgbClr val="193E3A"/>
@@ -7957,6 +7995,7 @@
           </a:lstStyle>
           <a:p xmlns:a="http://schemas.openxmlformats.org/drawingml/2006/main">
             <a:pPr>
+              <a:buNone/>
               <a:defRPr sz="1875" b="0">
                 <a:solidFill>
                   <a:srgbClr val="617C77"/>
@@ -8023,6 +8062,7 @@
           </a:lstStyle>
           <a:p xmlns:a="http://schemas.openxmlformats.org/drawingml/2006/main">
             <a:pPr>
+              <a:buNone/>
               <a:defRPr sz="1275" b="0">
                 <a:solidFill>
                   <a:srgbClr val="617C77"/>
@@ -9797,7 +9837,7 @@
           <p:cNvPr id="3" name="">
             <a:extLst xmlns:a="http://schemas.openxmlformats.org/drawingml/2006/main">
               <a:ext uri="{FF2B5EF4-FFF2-40B4-BE49-F238E27FC236}">
-                <a16:creationId xmlns:a16="http://schemas.microsoft.com/office/drawing/2014/main" id="{552B8B35-FDF6-4399-9ACC-BDAA6F68B054}"/>
+                <a16:creationId xmlns:a16="http://schemas.microsoft.com/office/drawing/2014/main" id="{58B8FE90-4DD2-4DD2-A78E-C7D13FAC61D0}"/>
               </a:ext>
             </a:extLst>
           </p:cNvPr>
@@ -11332,7 +11372,7 @@
           <p:cNvPr id="3" name="">
             <a:extLst xmlns:a="http://schemas.openxmlformats.org/drawingml/2006/main">
               <a:ext uri="{FF2B5EF4-FFF2-40B4-BE49-F238E27FC236}">
-                <a16:creationId xmlns:a16="http://schemas.microsoft.com/office/drawing/2014/main" id="{5D7C4D8C-20AA-4851-B234-6E704E6221EF}"/>
+                <a16:creationId xmlns:a16="http://schemas.microsoft.com/office/drawing/2014/main" id="{0DD6B0FA-CBF5-45EC-B56C-903EDD10F0B2}"/>
               </a:ext>
             </a:extLst>
           </p:cNvPr>
@@ -12893,7 +12933,7 @@
           <p:cNvPr id="3" name="">
             <a:extLst xmlns:a="http://schemas.openxmlformats.org/drawingml/2006/main">
               <a:ext uri="{FF2B5EF4-FFF2-40B4-BE49-F238E27FC236}">
-                <a16:creationId xmlns:a16="http://schemas.microsoft.com/office/drawing/2014/main" id="{CBF306E0-4F7F-4297-AAC0-AE015768BFA0}"/>
+                <a16:creationId xmlns:a16="http://schemas.microsoft.com/office/drawing/2014/main" id="{010FDF28-897B-4B2E-9453-1447E5D43B95}"/>
               </a:ext>
             </a:extLst>
           </p:cNvPr>
@@ -12903,7 +12943,7 @@
           <p:nvPr/>
         </p:nvPicPr>
         <p:blipFill>
-          <a:blip xmlns:r="http://schemas.openxmlformats.org/officeDocument/2006/relationships" xmlns:a="http://schemas.openxmlformats.org/drawingml/2006/main" r:embed="R8dfb66f403574a22"/>
+          <a:blip xmlns:r="http://schemas.openxmlformats.org/officeDocument/2006/relationships" xmlns:a="http://schemas.openxmlformats.org/drawingml/2006/main" r:embed="R82d8ee4662414081"/>
           <a:stretch xmlns:a="http://schemas.openxmlformats.org/drawingml/2006/main"/>
         </p:blipFill>
         <p:spPr>
@@ -13436,7 +13476,7 @@
           <p:cNvPr id="3" name="">
             <a:extLst xmlns:a="http://schemas.openxmlformats.org/drawingml/2006/main">
               <a:ext uri="{FF2B5EF4-FFF2-40B4-BE49-F238E27FC236}">
-                <a16:creationId xmlns:a16="http://schemas.microsoft.com/office/drawing/2014/main" id="{E807F53E-79C5-4102-B4DC-66C490B7D74A}"/>
+                <a16:creationId xmlns:a16="http://schemas.microsoft.com/office/drawing/2014/main" id="{113B492E-EB9E-4FFA-83A6-42930ABA20FF}"/>
               </a:ext>
             </a:extLst>
           </p:cNvPr>
@@ -13446,7 +13486,7 @@
           <p:nvPr/>
         </p:nvPicPr>
         <p:blipFill>
-          <a:blip xmlns:r="http://schemas.openxmlformats.org/officeDocument/2006/relationships" xmlns:a="http://schemas.openxmlformats.org/drawingml/2006/main" r:embed="Rd867fea79e2544da"/>
+          <a:blip xmlns:r="http://schemas.openxmlformats.org/officeDocument/2006/relationships" xmlns:a="http://schemas.openxmlformats.org/drawingml/2006/main" r:embed="R4eccb42090a1403e"/>
           <a:stretch xmlns:a="http://schemas.openxmlformats.org/drawingml/2006/main"/>
         </p:blipFill>
         <p:spPr>
@@ -13910,7 +13950,7 @@
           <p:cNvPr id="3" name="">
             <a:extLst xmlns:a="http://schemas.openxmlformats.org/drawingml/2006/main">
               <a:ext uri="{FF2B5EF4-FFF2-40B4-BE49-F238E27FC236}">
-                <a16:creationId xmlns:a16="http://schemas.microsoft.com/office/drawing/2014/main" id="{811E0E1C-71A9-4CEA-A0B9-BB62F60B36FB}"/>
+                <a16:creationId xmlns:a16="http://schemas.microsoft.com/office/drawing/2014/main" id="{43659F84-4F75-4855-B019-F49C2519DB07}"/>
               </a:ext>
             </a:extLst>
           </p:cNvPr>
@@ -13920,7 +13960,7 @@
           <p:nvPr/>
         </p:nvPicPr>
         <p:blipFill>
-          <a:blip xmlns:r="http://schemas.openxmlformats.org/officeDocument/2006/relationships" xmlns:a="http://schemas.openxmlformats.org/drawingml/2006/main" r:embed="Raac6e2ddc7d54d5d"/>
+          <a:blip xmlns:r="http://schemas.openxmlformats.org/officeDocument/2006/relationships" xmlns:a="http://schemas.openxmlformats.org/drawingml/2006/main" r:embed="R88e3ebc7afec49b6"/>
           <a:stretch xmlns:a="http://schemas.openxmlformats.org/drawingml/2006/main"/>
         </p:blipFill>
         <p:spPr>
@@ -13938,7 +13978,7 @@
           <p:cNvPr id="4" name="">
             <a:extLst xmlns:a="http://schemas.openxmlformats.org/drawingml/2006/main">
               <a:ext uri="{FF2B5EF4-FFF2-40B4-BE49-F238E27FC236}">
-                <a16:creationId xmlns:a16="http://schemas.microsoft.com/office/drawing/2014/main" id="{0B05D655-F408-4091-B82E-0615489332AB}"/>
+                <a16:creationId xmlns:a16="http://schemas.microsoft.com/office/drawing/2014/main" id="{53BF370D-A628-4EDC-8350-32C6D74D8E10}"/>
               </a:ext>
             </a:extLst>
           </p:cNvPr>
@@ -13948,7 +13988,7 @@
           <p:nvPr/>
         </p:nvPicPr>
         <p:blipFill>
-          <a:blip xmlns:r="http://schemas.openxmlformats.org/officeDocument/2006/relationships" xmlns:a="http://schemas.openxmlformats.org/drawingml/2006/main" r:embed="R932ec7af56c94e8c"/>
+          <a:blip xmlns:r="http://schemas.openxmlformats.org/officeDocument/2006/relationships" xmlns:a="http://schemas.openxmlformats.org/drawingml/2006/main" r:embed="Rce377cece6e747e6"/>
           <a:stretch xmlns:a="http://schemas.openxmlformats.org/drawingml/2006/main"/>
         </p:blipFill>
         <p:spPr>

</xml_diff>

<commit_message>
docs(ci): record successful GitHub Actions run and update project presentation
</commit_message>
<xml_diff>
--- a/presentation/tynys_complete_13slides_kz.pptx
+++ b/presentation/tynys_complete_13slides_kz.pptx
@@ -2,25 +2,25 @@
 <file path=ppt/presentation.xml><?xml version="1.0" encoding="utf-8"?>
 <p:presentation xmlns:p="http://schemas.openxmlformats.org/presentationml/2006/main">
   <p:sldMasterIdLst>
-    <p:sldMasterId xmlns:r="http://schemas.openxmlformats.org/officeDocument/2006/relationships" id="2147483648" r:id="R7133b67604874e45"/>
+    <p:sldMasterId xmlns:r="http://schemas.openxmlformats.org/officeDocument/2006/relationships" id="2147483648" r:id="Rea32883d28954938"/>
   </p:sldMasterIdLst>
   <p:notesMasterIdLst>
-    <p:notesMasterId xmlns:r="http://schemas.openxmlformats.org/officeDocument/2006/relationships" r:id="Rc726b13185bb4af5"/>
+    <p:notesMasterId xmlns:r="http://schemas.openxmlformats.org/officeDocument/2006/relationships" r:id="R9678782a0d824455"/>
   </p:notesMasterIdLst>
   <p:sldIdLst>
-    <p:sldId xmlns:r="http://schemas.openxmlformats.org/officeDocument/2006/relationships" id="256" r:id="R8ce250daa19b4396"/>
-    <p:sldId xmlns:r="http://schemas.openxmlformats.org/officeDocument/2006/relationships" id="257" r:id="R42dbae8a950347ee"/>
-    <p:sldId xmlns:r="http://schemas.openxmlformats.org/officeDocument/2006/relationships" id="258" r:id="R10bb771b51714ab4"/>
-    <p:sldId xmlns:r="http://schemas.openxmlformats.org/officeDocument/2006/relationships" id="259" r:id="Ra8c32243a0404733"/>
-    <p:sldId xmlns:r="http://schemas.openxmlformats.org/officeDocument/2006/relationships" id="260" r:id="R1a6c93958c334fcf"/>
-    <p:sldId xmlns:r="http://schemas.openxmlformats.org/officeDocument/2006/relationships" id="261" r:id="Rcc8afae33ab04c85"/>
-    <p:sldId xmlns:r="http://schemas.openxmlformats.org/officeDocument/2006/relationships" id="262" r:id="R00d2ea93340644b2"/>
-    <p:sldId xmlns:r="http://schemas.openxmlformats.org/officeDocument/2006/relationships" id="263" r:id="R51e75400c4484ae7"/>
-    <p:sldId xmlns:r="http://schemas.openxmlformats.org/officeDocument/2006/relationships" id="264" r:id="R7b6439df16a244e5"/>
-    <p:sldId xmlns:r="http://schemas.openxmlformats.org/officeDocument/2006/relationships" id="265" r:id="R7c23923ccf8e414d"/>
-    <p:sldId xmlns:r="http://schemas.openxmlformats.org/officeDocument/2006/relationships" id="266" r:id="R434027b0e27b48a1"/>
-    <p:sldId xmlns:r="http://schemas.openxmlformats.org/officeDocument/2006/relationships" id="267" r:id="R854e2d146a3c4ea3"/>
-    <p:sldId xmlns:r="http://schemas.openxmlformats.org/officeDocument/2006/relationships" id="268" r:id="Rc463d8a141e34166"/>
+    <p:sldId xmlns:r="http://schemas.openxmlformats.org/officeDocument/2006/relationships" id="256" r:id="R73dd33cc7ba94268"/>
+    <p:sldId xmlns:r="http://schemas.openxmlformats.org/officeDocument/2006/relationships" id="257" r:id="R127fffb8fef74878"/>
+    <p:sldId xmlns:r="http://schemas.openxmlformats.org/officeDocument/2006/relationships" id="258" r:id="R81c59207aa734ec0"/>
+    <p:sldId xmlns:r="http://schemas.openxmlformats.org/officeDocument/2006/relationships" id="259" r:id="R791d7a4587ab4399"/>
+    <p:sldId xmlns:r="http://schemas.openxmlformats.org/officeDocument/2006/relationships" id="260" r:id="R8aaf6434f0084d88"/>
+    <p:sldId xmlns:r="http://schemas.openxmlformats.org/officeDocument/2006/relationships" id="261" r:id="Rfa1a1a9dd0dc4e70"/>
+    <p:sldId xmlns:r="http://schemas.openxmlformats.org/officeDocument/2006/relationships" id="262" r:id="R6a49b7ddbdf44b57"/>
+    <p:sldId xmlns:r="http://schemas.openxmlformats.org/officeDocument/2006/relationships" id="263" r:id="R8c8cd68600e443dc"/>
+    <p:sldId xmlns:r="http://schemas.openxmlformats.org/officeDocument/2006/relationships" id="264" r:id="Rec1ebf50f8004387"/>
+    <p:sldId xmlns:r="http://schemas.openxmlformats.org/officeDocument/2006/relationships" id="265" r:id="R422e10db75924753"/>
+    <p:sldId xmlns:r="http://schemas.openxmlformats.org/officeDocument/2006/relationships" id="266" r:id="Raf02bda70cc546e3"/>
+    <p:sldId xmlns:r="http://schemas.openxmlformats.org/officeDocument/2006/relationships" id="267" r:id="Re44b1cac980143c1"/>
+    <p:sldId xmlns:r="http://schemas.openxmlformats.org/officeDocument/2006/relationships" id="268" r:id="R1345487b78f24536"/>
   </p:sldIdLst>
   <p:sldSz cx="12192000" cy="6858000"/>
   <p:notesSz cx="6858000" cy="9144000"/>
@@ -547,6 +547,16 @@
               <a:t>Дереккөз: training/docker_evidence/verification.json; live_result.json; container_logs.txt.</a:t>
             </a:r>
           </a:p>
+          <a:p xmlns:a="http://schemas.openxmlformats.org/drawingml/2006/main">
+            <a:r>
+              <a:t>GitHub CI Ubuntu/Python 3.11 ортасында қашықта орындалып, 56 тест сәтті өтті.</a:t>
+            </a:r>
+          </a:p>
+          <a:p xmlns:a="http://schemas.openxmlformats.org/drawingml/2006/main">
+            <a:r>
+              <a:t>Дереккөз: https://github.com/5kairosh/Tynys/actions/runs/38745485393; training/ci_evidence/pytest_success.txt.</a:t>
+            </a:r>
+          </a:p>
         </p:txBody>
       </p:sp>
       <p:sp>
@@ -3237,12 +3247,12 @@
   </p:cSld>
   <p:clrMap bg1="lt1" tx1="dk1" bg2="lt2" tx2="dk2" accent1="accent1" accent2="accent2" accent3="accent3" accent4="accent4" accent5="accent5" accent6="accent6" hlink="hlink" folHlink="folHlink"/>
   <p:sldLayoutIdLst>
-    <p:sldLayoutId xmlns:r="http://schemas.openxmlformats.org/officeDocument/2006/relationships" id="2147483649" r:id="R2be6fa4635e540e0"/>
-    <p:sldLayoutId xmlns:r="http://schemas.openxmlformats.org/officeDocument/2006/relationships" id="2147483650" r:id="R02908bd480144b28"/>
-    <p:sldLayoutId xmlns:r="http://schemas.openxmlformats.org/officeDocument/2006/relationships" id="2147483651" r:id="Rdd2d9481874c48dd"/>
-    <p:sldLayoutId xmlns:r="http://schemas.openxmlformats.org/officeDocument/2006/relationships" id="2147483652" r:id="R77d303c3b42543d9"/>
-    <p:sldLayoutId xmlns:r="http://schemas.openxmlformats.org/officeDocument/2006/relationships" id="2147483653" r:id="Rdcfd2d9f333d49a6"/>
-    <p:sldLayoutId xmlns:r="http://schemas.openxmlformats.org/officeDocument/2006/relationships" id="2147483654" r:id="R44126239cce04f8f"/>
+    <p:sldLayoutId xmlns:r="http://schemas.openxmlformats.org/officeDocument/2006/relationships" id="2147483649" r:id="R368d6b3bb2d04b3a"/>
+    <p:sldLayoutId xmlns:r="http://schemas.openxmlformats.org/officeDocument/2006/relationships" id="2147483650" r:id="R13a9b07434a04258"/>
+    <p:sldLayoutId xmlns:r="http://schemas.openxmlformats.org/officeDocument/2006/relationships" id="2147483651" r:id="Rbe23cd040ca34118"/>
+    <p:sldLayoutId xmlns:r="http://schemas.openxmlformats.org/officeDocument/2006/relationships" id="2147483652" r:id="R36ce6391d2c8479d"/>
+    <p:sldLayoutId xmlns:r="http://schemas.openxmlformats.org/officeDocument/2006/relationships" id="2147483653" r:id="R07bb2b1bb5694009"/>
+    <p:sldLayoutId xmlns:r="http://schemas.openxmlformats.org/officeDocument/2006/relationships" id="2147483654" r:id="R3c14129546054633"/>
   </p:sldLayoutIdLst>
   <p:txStyles>
     <p:titleStyle>
@@ -3862,7 +3872,7 @@
           <p:cNvPr id="2" name="">
             <a:extLst xmlns:a="http://schemas.openxmlformats.org/drawingml/2006/main">
               <a:ext uri="{FF2B5EF4-FFF2-40B4-BE49-F238E27FC236}">
-                <a16:creationId xmlns:a16="http://schemas.microsoft.com/office/drawing/2014/main" id="{F0087381-6866-4165-87E8-448B1F5DB1AD}"/>
+                <a16:creationId xmlns:a16="http://schemas.microsoft.com/office/drawing/2014/main" id="{C00A2D47-5673-4E15-A7BA-C633E216B756}"/>
               </a:ext>
             </a:extLst>
           </p:cNvPr>
@@ -3872,7 +3882,7 @@
           <p:nvPr/>
         </p:nvPicPr>
         <p:blipFill>
-          <a:blip xmlns:r="http://schemas.openxmlformats.org/officeDocument/2006/relationships" xmlns:a="http://schemas.openxmlformats.org/drawingml/2006/main" r:embed="R4391085b0def4d7d"/>
+          <a:blip xmlns:r="http://schemas.openxmlformats.org/officeDocument/2006/relationships" xmlns:a="http://schemas.openxmlformats.org/drawingml/2006/main" r:embed="R6f072ae253c14795"/>
           <a:stretch xmlns:a="http://schemas.openxmlformats.org/drawingml/2006/main"/>
         </p:blipFill>
         <p:spPr>
@@ -4417,7 +4427,7 @@
         <p:spPr>
           <a:xfrm xmlns:a="http://schemas.openxmlformats.org/drawingml/2006/main">
             <a:off x="619125" y="2524125"/>
-            <a:ext cx="5334000" cy="2105025"/>
+            <a:ext cx="5334000" cy="2428875"/>
           </a:xfrm>
           <a:prstGeom xmlns:a="http://schemas.openxmlformats.org/drawingml/2006/main" prst="rect">
             <a:avLst/>
@@ -4561,6 +4571,30 @@
                 <a:cs typeface="Arial"/>
               </a:rPr>
               <a:t>Docker build/run тексерілді</a:t>
+            </a:r>
+          </a:p>
+          <a:p xmlns:a="http://schemas.openxmlformats.org/drawingml/2006/main">
+            <a:pPr>
+              <a:buNone/>
+              <a:defRPr sz="2250" b="0">
+                <a:solidFill>
+                  <a:srgbClr val="FFFFFF"/>
+                </a:solidFill>
+                <a:latin typeface="Arial"/>
+                <a:ea typeface="Arial"/>
+                <a:cs typeface="Arial"/>
+              </a:defRPr>
+            </a:pPr>
+            <a:r>
+              <a:rPr sz="2250" b="0">
+                <a:solidFill>
+                  <a:srgbClr val="FFFFFF"/>
+                </a:solidFill>
+                <a:latin typeface="Arial"/>
+                <a:ea typeface="Arial"/>
+                <a:cs typeface="Arial"/>
+              </a:rPr>
+              <a:t>GitHub CI қашықта өтті</a:t>
             </a:r>
           </a:p>
         </p:txBody>
@@ -5085,7 +5119,7 @@
           <p:cNvPr id="3" name="">
             <a:extLst xmlns:a="http://schemas.openxmlformats.org/drawingml/2006/main">
               <a:ext uri="{FF2B5EF4-FFF2-40B4-BE49-F238E27FC236}">
-                <a16:creationId xmlns:a16="http://schemas.microsoft.com/office/drawing/2014/main" id="{7100581A-A842-4B21-A8C0-0FD0B9782DAF}"/>
+                <a16:creationId xmlns:a16="http://schemas.microsoft.com/office/drawing/2014/main" id="{56B0AC7D-6AB1-4447-86E8-1C95589BE7E2}"/>
               </a:ext>
             </a:extLst>
           </p:cNvPr>
@@ -7183,7 +7217,7 @@
           <p:cNvPr id="2" name="">
             <a:extLst xmlns:a="http://schemas.openxmlformats.org/drawingml/2006/main">
               <a:ext uri="{FF2B5EF4-FFF2-40B4-BE49-F238E27FC236}">
-                <a16:creationId xmlns:a16="http://schemas.microsoft.com/office/drawing/2014/main" id="{FA455FDA-BA04-44E3-939B-574507BEAEAE}"/>
+                <a16:creationId xmlns:a16="http://schemas.microsoft.com/office/drawing/2014/main" id="{2BF16C0A-71E3-487F-BCC5-E3A9FB2CB9C9}"/>
               </a:ext>
             </a:extLst>
           </p:cNvPr>
@@ -9837,7 +9871,7 @@
           <p:cNvPr id="3" name="">
             <a:extLst xmlns:a="http://schemas.openxmlformats.org/drawingml/2006/main">
               <a:ext uri="{FF2B5EF4-FFF2-40B4-BE49-F238E27FC236}">
-                <a16:creationId xmlns:a16="http://schemas.microsoft.com/office/drawing/2014/main" id="{58B8FE90-4DD2-4DD2-A78E-C7D13FAC61D0}"/>
+                <a16:creationId xmlns:a16="http://schemas.microsoft.com/office/drawing/2014/main" id="{E9965083-1B57-44D9-ABCA-E00907CE4532}"/>
               </a:ext>
             </a:extLst>
           </p:cNvPr>
@@ -11372,7 +11406,7 @@
           <p:cNvPr id="3" name="">
             <a:extLst xmlns:a="http://schemas.openxmlformats.org/drawingml/2006/main">
               <a:ext uri="{FF2B5EF4-FFF2-40B4-BE49-F238E27FC236}">
-                <a16:creationId xmlns:a16="http://schemas.microsoft.com/office/drawing/2014/main" id="{0DD6B0FA-CBF5-45EC-B56C-903EDD10F0B2}"/>
+                <a16:creationId xmlns:a16="http://schemas.microsoft.com/office/drawing/2014/main" id="{E85CB66F-B11A-40A6-BAF7-B79A648B447A}"/>
               </a:ext>
             </a:extLst>
           </p:cNvPr>
@@ -12933,7 +12967,7 @@
           <p:cNvPr id="3" name="">
             <a:extLst xmlns:a="http://schemas.openxmlformats.org/drawingml/2006/main">
               <a:ext uri="{FF2B5EF4-FFF2-40B4-BE49-F238E27FC236}">
-                <a16:creationId xmlns:a16="http://schemas.microsoft.com/office/drawing/2014/main" id="{010FDF28-897B-4B2E-9453-1447E5D43B95}"/>
+                <a16:creationId xmlns:a16="http://schemas.microsoft.com/office/drawing/2014/main" id="{F603041F-B7F7-44A4-8B07-174F3217B42D}"/>
               </a:ext>
             </a:extLst>
           </p:cNvPr>
@@ -12943,7 +12977,7 @@
           <p:nvPr/>
         </p:nvPicPr>
         <p:blipFill>
-          <a:blip xmlns:r="http://schemas.openxmlformats.org/officeDocument/2006/relationships" xmlns:a="http://schemas.openxmlformats.org/drawingml/2006/main" r:embed="R82d8ee4662414081"/>
+          <a:blip xmlns:r="http://schemas.openxmlformats.org/officeDocument/2006/relationships" xmlns:a="http://schemas.openxmlformats.org/drawingml/2006/main" r:embed="Rbd6fde4f2e71486b"/>
           <a:stretch xmlns:a="http://schemas.openxmlformats.org/drawingml/2006/main"/>
         </p:blipFill>
         <p:spPr>
@@ -13476,7 +13510,7 @@
           <p:cNvPr id="3" name="">
             <a:extLst xmlns:a="http://schemas.openxmlformats.org/drawingml/2006/main">
               <a:ext uri="{FF2B5EF4-FFF2-40B4-BE49-F238E27FC236}">
-                <a16:creationId xmlns:a16="http://schemas.microsoft.com/office/drawing/2014/main" id="{113B492E-EB9E-4FFA-83A6-42930ABA20FF}"/>
+                <a16:creationId xmlns:a16="http://schemas.microsoft.com/office/drawing/2014/main" id="{7F4084FE-5600-4FCC-8BA5-4DE0621FE1F0}"/>
               </a:ext>
             </a:extLst>
           </p:cNvPr>
@@ -13486,7 +13520,7 @@
           <p:nvPr/>
         </p:nvPicPr>
         <p:blipFill>
-          <a:blip xmlns:r="http://schemas.openxmlformats.org/officeDocument/2006/relationships" xmlns:a="http://schemas.openxmlformats.org/drawingml/2006/main" r:embed="R4eccb42090a1403e"/>
+          <a:blip xmlns:r="http://schemas.openxmlformats.org/officeDocument/2006/relationships" xmlns:a="http://schemas.openxmlformats.org/drawingml/2006/main" r:embed="R758e709892ab49a0"/>
           <a:stretch xmlns:a="http://schemas.openxmlformats.org/drawingml/2006/main"/>
         </p:blipFill>
         <p:spPr>
@@ -13950,7 +13984,7 @@
           <p:cNvPr id="3" name="">
             <a:extLst xmlns:a="http://schemas.openxmlformats.org/drawingml/2006/main">
               <a:ext uri="{FF2B5EF4-FFF2-40B4-BE49-F238E27FC236}">
-                <a16:creationId xmlns:a16="http://schemas.microsoft.com/office/drawing/2014/main" id="{43659F84-4F75-4855-B019-F49C2519DB07}"/>
+                <a16:creationId xmlns:a16="http://schemas.microsoft.com/office/drawing/2014/main" id="{F129D24F-B4D6-4FF3-A14A-F6A49B86D17C}"/>
               </a:ext>
             </a:extLst>
           </p:cNvPr>
@@ -13960,7 +13994,7 @@
           <p:nvPr/>
         </p:nvPicPr>
         <p:blipFill>
-          <a:blip xmlns:r="http://schemas.openxmlformats.org/officeDocument/2006/relationships" xmlns:a="http://schemas.openxmlformats.org/drawingml/2006/main" r:embed="R88e3ebc7afec49b6"/>
+          <a:blip xmlns:r="http://schemas.openxmlformats.org/officeDocument/2006/relationships" xmlns:a="http://schemas.openxmlformats.org/drawingml/2006/main" r:embed="Rd4737f42fac74128"/>
           <a:stretch xmlns:a="http://schemas.openxmlformats.org/drawingml/2006/main"/>
         </p:blipFill>
         <p:spPr>
@@ -13978,7 +14012,7 @@
           <p:cNvPr id="4" name="">
             <a:extLst xmlns:a="http://schemas.openxmlformats.org/drawingml/2006/main">
               <a:ext uri="{FF2B5EF4-FFF2-40B4-BE49-F238E27FC236}">
-                <a16:creationId xmlns:a16="http://schemas.microsoft.com/office/drawing/2014/main" id="{53BF370D-A628-4EDC-8350-32C6D74D8E10}"/>
+                <a16:creationId xmlns:a16="http://schemas.microsoft.com/office/drawing/2014/main" id="{3D054BD5-45E8-4CE0-9DE4-C6258C14876D}"/>
               </a:ext>
             </a:extLst>
           </p:cNvPr>
@@ -13988,7 +14022,7 @@
           <p:nvPr/>
         </p:nvPicPr>
         <p:blipFill>
-          <a:blip xmlns:r="http://schemas.openxmlformats.org/officeDocument/2006/relationships" xmlns:a="http://schemas.openxmlformats.org/drawingml/2006/main" r:embed="Rce377cece6e747e6"/>
+          <a:blip xmlns:r="http://schemas.openxmlformats.org/officeDocument/2006/relationships" xmlns:a="http://schemas.openxmlformats.org/drawingml/2006/main" r:embed="Rf4c90fff373141c4"/>
           <a:stretch xmlns:a="http://schemas.openxmlformats.org/drawingml/2006/main"/>
         </p:blipFill>
         <p:spPr>

</xml_diff>